<commit_message>
V9 case: enlarge expert portrait (856 px, bleeds off right edge), 52 px heading; rebuild templates
Co-Authored-By: Claude Sonnet 5.5 <noreply@anthropic.com>
Claude-Session: https://claude.ai/code/session_01VZ7Hrkur6jxoGp5f6QSiLJ
</commit_message>
<xml_diff>
--- a/editable/1plus1-templates.pptx
+++ b/editable/1plus1-templates.pptx
@@ -9134,8 +9134,8 @@
         </p:blipFill>
         <p:spPr>
           <a:xfrm>
-            <a:off x="5761434" y="4953000"/>
-            <a:ext cx="4335065" cy="5334000"/>
+            <a:off x="4327326" y="2133600"/>
+            <a:ext cx="6626423" cy="8153400"/>
           </a:xfrm>
           <a:prstGeom prst="rect">
             <a:avLst/>
@@ -9233,8 +9233,8 @@
         </p:nvSpPr>
         <p:spPr>
           <a:xfrm>
-            <a:off x="914400" y="3204210"/>
-            <a:ext cx="9144000" cy="2560320"/>
+            <a:off x="914400" y="3203829"/>
+            <a:ext cx="9144000" cy="2258568"/>
           </a:xfrm>
           <a:prstGeom prst="rect">
             <a:avLst/>
@@ -9247,11 +9247,11 @@
           <a:p>
             <a:pPr algn="l">
               <a:lnSpc>
-                <a:spcPts val="5040"/>
+                <a:spcPts val="4446"/>
               </a:lnSpc>
             </a:pPr>
             <a:r>
-              <a:rPr b="0" sz="4500" spc="-90">
+              <a:rPr b="0" sz="3900" spc="-78">
                 <a:solidFill>
                   <a:srgbClr val="1C1A17"/>
                 </a:solidFill>
@@ -9263,7 +9263,7 @@
             </a:r>
             <a:br/>
             <a:r>
-              <a:rPr b="0" sz="4500" spc="-90">
+              <a:rPr b="0" sz="3900" spc="-78">
                 <a:solidFill>
                   <a:srgbClr val="1C1A17"/>
                 </a:solidFill>
@@ -9275,7 +9275,7 @@
             </a:r>
             <a:br/>
             <a:r>
-              <a:rPr b="0" sz="4500" spc="-90">
+              <a:rPr b="0" sz="3900" spc="-78">
                 <a:solidFill>
                   <a:srgbClr val="D73A61"/>
                 </a:solidFill>
@@ -9286,7 +9286,7 @@
               <a:t>сумма</a:t>
             </a:r>
             <a:r>
-              <a:rPr b="0" sz="4500" spc="-90">
+              <a:rPr b="0" sz="3900" spc="-78">
                 <a:solidFill>
                   <a:srgbClr val="1C1A17"/>
                 </a:solidFill>
@@ -9298,7 +9298,7 @@
             </a:r>
             <a:br/>
             <a:r>
-              <a:rPr b="0" sz="4500" spc="-90">
+              <a:rPr b="0" sz="3900" spc="-78">
                 <a:solidFill>
                   <a:srgbClr val="1C1A17"/>
                 </a:solidFill>

</xml_diff>

<commit_message>
Ticker urgent-news variant with green label and dots; templates updated
Co-Authored-By: Claude Sonnet 5.5 <noreply@anthropic.com>
Claude-Session: https://claude.ai/code/session_01VZ7Hrkur6jxoGp5f6QSiLJ
</commit_message>
<xml_diff>
--- a/editable/1plus1-templates.pptx
+++ b/editable/1plus1-templates.pptx
@@ -6698,7 +6698,7 @@
 
 <file path=ppt/slides/slide17.xml><?xml version="1.0" encoding="utf-8"?>
 <p:sld xmlns:a="http://schemas.openxmlformats.org/drawingml/2006/main" xmlns:p="http://schemas.openxmlformats.org/presentationml/2006/main" xmlns:r="http://schemas.openxmlformats.org/officeDocument/2006/relationships">
-  <p:cSld name="U6-urgent-ticker-quiet">
+  <p:cSld name="U6-urgent-ticker-green">
     <p:spTree>
       <p:nvGrpSpPr>
         <p:cNvPr id="1" name=""/>
@@ -6732,7 +6732,7 @@
       </p:sp>
       <p:pic>
         <p:nvPicPr>
-          <p:cNvPr id="4" name="Фон (картинка, без текста)" descr="U6-urgent-ticker-quiet-bg.png"/>
+          <p:cNvPr id="4" name="Фон (картинка, без текста)" descr="U6-urgent-ticker-green-bg.png"/>
           <p:cNvPicPr>
             <a:picLocks noChangeAspect="1"/>
           </p:cNvPicPr>

</xml_diff>